<commit_message>
add fixes with presentation and model card
</commit_message>
<xml_diff>
--- a/Presentation.pptx
+++ b/Presentation.pptx
@@ -283,7 +283,7 @@
           <a:p>
             <a:fld id="{C4270120-CDFC-48DE-A6EA-6DEEDD0E436A}" type="datetimeFigureOut">
               <a:rPr lang="en-US" dirty="0"/>
-              <a:t>12/1/2025</a:t>
+              <a:t>12/2/2025</a:t>
             </a:fld>
             <a:endParaRPr lang="en-US" dirty="0"/>
           </a:p>
@@ -577,7 +577,7 @@
           <a:p>
             <a:fld id="{2A1F5BA7-0A17-4D30-9B66-E29324151C73}" type="datetimeFigureOut">
               <a:rPr lang="en-US" dirty="0"/>
-              <a:t>12/1/2025</a:t>
+              <a:t>12/2/2025</a:t>
             </a:fld>
             <a:endParaRPr lang="en-US" dirty="0"/>
           </a:p>
@@ -833,7 +833,7 @@
           <a:p>
             <a:fld id="{76BEBB1B-D40A-4DB9-B3DE-BAAE675B83CD}" type="datetimeFigureOut">
               <a:rPr lang="en-US" dirty="0"/>
-              <a:t>12/1/2025</a:t>
+              <a:t>12/2/2025</a:t>
             </a:fld>
             <a:endParaRPr lang="en-US" dirty="0"/>
           </a:p>
@@ -1089,7 +1089,7 @@
           <a:p>
             <a:fld id="{A3C9FAAF-C467-4C93-8ECD-39AF5A14D498}" type="datetimeFigureOut">
               <a:rPr lang="en-US" dirty="0"/>
-              <a:t>12/1/2025</a:t>
+              <a:t>12/2/2025</a:t>
             </a:fld>
             <a:endParaRPr lang="en-US" dirty="0"/>
           </a:p>
@@ -1414,7 +1414,7 @@
           <a:p>
             <a:fld id="{3E37E480-B2BA-4553-A144-61E7F75833ED}" type="datetimeFigureOut">
               <a:rPr lang="en-US" dirty="0"/>
-              <a:t>12/1/2025</a:t>
+              <a:t>12/2/2025</a:t>
             </a:fld>
             <a:endParaRPr lang="en-US" dirty="0"/>
           </a:p>
@@ -1768,7 +1768,7 @@
           <a:p>
             <a:fld id="{390E682A-6B53-4B08-AE4D-4C5E659103CC}" type="datetimeFigureOut">
               <a:rPr lang="en-US" dirty="0"/>
-              <a:t>12/1/2025</a:t>
+              <a:t>12/2/2025</a:t>
             </a:fld>
             <a:endParaRPr lang="en-US" dirty="0"/>
           </a:p>
@@ -2284,7 +2284,7 @@
           <a:p>
             <a:fld id="{7C69F0F6-BEBB-4894-ABB2-75C5CBE0DDB9}" type="datetimeFigureOut">
               <a:rPr lang="en-US" dirty="0"/>
-              <a:t>12/1/2025</a:t>
+              <a:t>12/2/2025</a:t>
             </a:fld>
             <a:endParaRPr lang="en-US" dirty="0"/>
           </a:p>
@@ -2600,7 +2600,7 @@
           <a:p>
             <a:fld id="{8B3E9E5F-17D9-4A30-9DA3-64E46A6DF111}" type="datetimeFigureOut">
               <a:rPr lang="en-US" dirty="0"/>
-              <a:t>12/1/2025</a:t>
+              <a:t>12/2/2025</a:t>
             </a:fld>
             <a:endParaRPr lang="en-US" dirty="0"/>
           </a:p>
@@ -2717,7 +2717,7 @@
           <a:p>
             <a:fld id="{033AC5F0-3BC3-4718-BCCA-24B5655EC864}" type="datetimeFigureOut">
               <a:rPr lang="en-US" dirty="0"/>
-              <a:t>12/1/2025</a:t>
+              <a:t>12/2/2025</a:t>
             </a:fld>
             <a:endParaRPr lang="en-US" dirty="0"/>
           </a:p>
@@ -3062,7 +3062,7 @@
           <a:p>
             <a:fld id="{9EB8BD81-465B-40F2-9A54-9DF3B12AF598}" type="datetimeFigureOut">
               <a:rPr lang="en-US" dirty="0"/>
-              <a:t>12/1/2025</a:t>
+              <a:t>12/2/2025</a:t>
             </a:fld>
             <a:endParaRPr lang="en-US" dirty="0"/>
           </a:p>
@@ -3366,7 +3366,7 @@
           <a:p>
             <a:fld id="{F04B3CEF-64EF-4C43-9530-8E9CBFD2CAD1}" type="datetimeFigureOut">
               <a:rPr lang="en-US" dirty="0"/>
-              <a:t>12/1/2025</a:t>
+              <a:t>12/2/2025</a:t>
             </a:fld>
             <a:endParaRPr lang="en-US" dirty="0"/>
           </a:p>
@@ -3609,7 +3609,7 @@
           <a:p>
             <a:fld id="{B70A3DFD-A535-46B2-84C1-61DC8B16A904}" type="datetimeFigureOut">
               <a:rPr lang="en-US" dirty="0"/>
-              <a:t>12/1/2025</a:t>
+              <a:t>12/2/2025</a:t>
             </a:fld>
             <a:endParaRPr lang="en-US" dirty="0"/>
           </a:p>
@@ -4519,7 +4519,7 @@
           <a:lstStyle/>
           <a:p>
             <a:fld id="{AD6E1EBF-D5B7-43F2-A5E2-415383AEF6CD}" type="datetime1">
-              <a:t>12/1/2025</a:t>
+              <a:t>02.12.2025</a:t>
             </a:fld>
             <a:endParaRPr lang="en-US" dirty="0"/>
           </a:p>
@@ -4688,7 +4688,7 @@
           <a:lstStyle/>
           <a:p>
             <a:fld id="{F0A60714-C537-4438-9452-296D528D6BEB}" type="datetime1">
-              <a:t>12/1/2025</a:t>
+              <a:t>02.12.2025</a:t>
             </a:fld>
             <a:endParaRPr lang="en-US"/>
           </a:p>
@@ -5390,7 +5390,8 @@
           <a:lstStyle/>
           <a:p>
             <a:fld id="{7EE0C613-8EA2-49AF-AAE4-34430B334CE9}" type="datetime1">
-              <a:t>12/1/2025</a:t>
+              <a:rPr lang="pl-PL"/>
+              <a:t>02.12.2025</a:t>
             </a:fld>
             <a:endParaRPr lang="en-US"/>
           </a:p>
@@ -5900,7 +5901,7 @@
           <a:lstStyle/>
           <a:p>
             <a:fld id="{7EE0C613-8EA2-49AF-AAE4-34430B334CE9}" type="datetime1">
-              <a:t>12/1/2025</a:t>
+              <a:t>02.12.2025</a:t>
             </a:fld>
             <a:endParaRPr lang="en-US" dirty="0"/>
           </a:p>
@@ -6685,6 +6686,69 @@
           </a:graphicData>
         </a:graphic>
       </p:graphicFrame>
+      <p:sp>
+        <p:nvSpPr>
+          <p:cNvPr id="3" name="pole tekstowe 2">
+            <a:extLst>
+              <a:ext uri="{FF2B5EF4-FFF2-40B4-BE49-F238E27FC236}">
+                <a16:creationId xmlns:a16="http://schemas.microsoft.com/office/drawing/2014/main" id="{0A324B48-A114-F0B2-AE38-4231E87EFDA6}"/>
+              </a:ext>
+            </a:extLst>
+          </p:cNvPr>
+          <p:cNvSpPr txBox="1"/>
+          <p:nvPr/>
+        </p:nvSpPr>
+        <p:spPr>
+          <a:xfrm>
+            <a:off x="7519147" y="2173941"/>
+            <a:ext cx="3866029" cy="646331"/>
+          </a:xfrm>
+          <a:prstGeom prst="rect">
+            <a:avLst/>
+          </a:prstGeom>
+          <a:noFill/>
+        </p:spPr>
+        <p:txBody>
+          <a:bodyPr wrap="square" rtlCol="0">
+            <a:spAutoFit/>
+          </a:bodyPr>
+          <a:lstStyle/>
+          <a:p>
+            <a:r>
+              <a:rPr lang="pl-PL" dirty="0" err="1">
+                <a:latin typeface="Calibri" panose="020F0502020204030204" pitchFamily="34" charset="0"/>
+                <a:ea typeface="Calibri" panose="020F0502020204030204" pitchFamily="34" charset="0"/>
+                <a:cs typeface="Calibri" panose="020F0502020204030204" pitchFamily="34" charset="0"/>
+              </a:rPr>
+              <a:t>Profilo</a:t>
+            </a:r>
+            <a:r>
+              <a:rPr lang="pl-PL" dirty="0">
+                <a:latin typeface="Calibri" panose="020F0502020204030204" pitchFamily="34" charset="0"/>
+                <a:ea typeface="Calibri" panose="020F0502020204030204" pitchFamily="34" charset="0"/>
+                <a:cs typeface="Calibri" panose="020F0502020204030204" pitchFamily="34" charset="0"/>
+              </a:rPr>
+              <a:t> </a:t>
+            </a:r>
+            <a:r>
+              <a:rPr lang="pl-PL" dirty="0" err="1">
+                <a:latin typeface="Calibri" panose="020F0502020204030204" pitchFamily="34" charset="0"/>
+                <a:ea typeface="Calibri" panose="020F0502020204030204" pitchFamily="34" charset="0"/>
+                <a:cs typeface="Calibri" panose="020F0502020204030204" pitchFamily="34" charset="0"/>
+              </a:rPr>
+              <a:t>WoE</a:t>
+            </a:r>
+            <a:r>
+              <a:rPr lang="pl-PL" dirty="0">
+                <a:latin typeface="Calibri" panose="020F0502020204030204" pitchFamily="34" charset="0"/>
+                <a:ea typeface="Calibri" panose="020F0502020204030204" pitchFamily="34" charset="0"/>
+                <a:cs typeface="Calibri" panose="020F0502020204030204" pitchFamily="34" charset="0"/>
+              </a:rPr>
+              <a:t> dla wskaźnika mnożnika kapitału własnego:</a:t>
+            </a:r>
+          </a:p>
+        </p:txBody>
+      </p:sp>
     </p:spTree>
     <p:extLst>
       <p:ext uri="{BB962C8B-B14F-4D97-AF65-F5344CB8AC3E}">
@@ -6910,7 +6974,8 @@
           <a:lstStyle/>
           <a:p>
             <a:fld id="{3520EEF0-31D2-4846-A48F-4F898E20454F}" type="datetime1">
-              <a:t>12/1/2025</a:t>
+              <a:rPr lang="pl-PL"/>
+              <a:t>02.12.2025</a:t>
             </a:fld>
             <a:endParaRPr lang="en-US" dirty="0"/>
           </a:p>
@@ -7976,7 +8041,8 @@
           <a:lstStyle/>
           <a:p>
             <a:fld id="{5FCAC423-9313-454E-A098-8D3021A3AC0B}" type="datetime1">
-              <a:t>12/1/2025</a:t>
+              <a:rPr lang="pl-PL"/>
+              <a:t>02.12.2025</a:t>
             </a:fld>
             <a:endParaRPr lang="en-US"/>
           </a:p>

</xml_diff>